<commit_message>
fix(slides): update intro slides
</commit_message>
<xml_diff>
--- a/slides/flsg/1-intro-flsg.pptx
+++ b/slides/flsg/1-intro-flsg.pptx
@@ -315,7 +315,7 @@
           </a:lstStyle>
           <a:p>
             <a:fld id="{2DE082D9-00CE-4FDC-82D3-FDE16CD37225}" type="datetimeFigureOut">
-              <a:t>5/14/26</a:t>
+              <a:t>6/22/26</a:t>
             </a:fld>
             <a:endParaRPr lang="en-US"/>
           </a:p>
@@ -1044,7 +1044,7 @@
           <a:p>
             <a:r>
               <a:rPr lang="en-US" dirty="0"/>
-              <a:t>Workshops (see in a second) and  AI Clinic</a:t>
+              <a:t>Workshops (see in a second) and  AI Clinic (see in a second)</a:t>
             </a:r>
           </a:p>
           <a:p>
@@ -1974,7 +1974,7 @@
           <a:p>
             <a:fld id="{C764DE79-268F-4C1A-8933-263129D2AF90}" type="datetimeFigureOut">
               <a:rPr lang="en-US" dirty="0"/>
-              <a:t>5/14/26</a:t>
+              <a:t>6/22/26</a:t>
             </a:fld>
             <a:endParaRPr lang="en-US" dirty="0"/>
           </a:p>
@@ -2142,7 +2142,7 @@
           <a:p>
             <a:fld id="{C764DE79-268F-4C1A-8933-263129D2AF90}" type="datetimeFigureOut">
               <a:rPr lang="en-US" dirty="0"/>
-              <a:t>5/14/26</a:t>
+              <a:t>6/22/26</a:t>
             </a:fld>
             <a:endParaRPr lang="en-US" dirty="0"/>
           </a:p>
@@ -2320,7 +2320,7 @@
           <a:p>
             <a:fld id="{C764DE79-268F-4C1A-8933-263129D2AF90}" type="datetimeFigureOut">
               <a:rPr lang="en-US" dirty="0"/>
-              <a:t>5/14/26</a:t>
+              <a:t>6/22/26</a:t>
             </a:fld>
             <a:endParaRPr lang="en-US" dirty="0"/>
           </a:p>
@@ -2488,7 +2488,7 @@
           <a:p>
             <a:fld id="{C764DE79-268F-4C1A-8933-263129D2AF90}" type="datetimeFigureOut">
               <a:rPr lang="en-US" dirty="0"/>
-              <a:t>5/14/26</a:t>
+              <a:t>6/22/26</a:t>
             </a:fld>
             <a:endParaRPr lang="en-US" dirty="0"/>
           </a:p>
@@ -2733,7 +2733,7 @@
           <a:p>
             <a:fld id="{C764DE79-268F-4C1A-8933-263129D2AF90}" type="datetimeFigureOut">
               <a:rPr lang="en-US" dirty="0"/>
-              <a:t>5/14/26</a:t>
+              <a:t>6/22/26</a:t>
             </a:fld>
             <a:endParaRPr lang="en-US" dirty="0"/>
           </a:p>
@@ -2962,7 +2962,7 @@
           <a:p>
             <a:fld id="{C764DE79-268F-4C1A-8933-263129D2AF90}" type="datetimeFigureOut">
               <a:rPr lang="en-US" dirty="0"/>
-              <a:t>5/14/26</a:t>
+              <a:t>6/22/26</a:t>
             </a:fld>
             <a:endParaRPr lang="en-US" dirty="0"/>
           </a:p>
@@ -3326,7 +3326,7 @@
           <a:p>
             <a:fld id="{C764DE79-268F-4C1A-8933-263129D2AF90}" type="datetimeFigureOut">
               <a:rPr lang="en-US" dirty="0"/>
-              <a:t>5/14/26</a:t>
+              <a:t>6/22/26</a:t>
             </a:fld>
             <a:endParaRPr lang="en-US" dirty="0"/>
           </a:p>
@@ -3443,7 +3443,7 @@
           <a:p>
             <a:fld id="{C764DE79-268F-4C1A-8933-263129D2AF90}" type="datetimeFigureOut">
               <a:rPr lang="en-US" dirty="0"/>
-              <a:t>5/14/26</a:t>
+              <a:t>6/22/26</a:t>
             </a:fld>
             <a:endParaRPr lang="en-US" dirty="0"/>
           </a:p>
@@ -3538,7 +3538,7 @@
           <a:p>
             <a:fld id="{C764DE79-268F-4C1A-8933-263129D2AF90}" type="datetimeFigureOut">
               <a:rPr lang="en-US" dirty="0"/>
-              <a:t>5/14/26</a:t>
+              <a:t>6/22/26</a:t>
             </a:fld>
             <a:endParaRPr lang="en-US" dirty="0"/>
           </a:p>
@@ -3813,7 +3813,7 @@
           <a:p>
             <a:fld id="{C764DE79-268F-4C1A-8933-263129D2AF90}" type="datetimeFigureOut">
               <a:rPr lang="en-US" dirty="0"/>
-              <a:t>5/14/26</a:t>
+              <a:t>6/22/26</a:t>
             </a:fld>
             <a:endParaRPr lang="en-US" dirty="0"/>
           </a:p>
@@ -4065,7 +4065,7 @@
           <a:p>
             <a:fld id="{C764DE79-268F-4C1A-8933-263129D2AF90}" type="datetimeFigureOut">
               <a:rPr lang="en-US" dirty="0"/>
-              <a:t>5/14/26</a:t>
+              <a:t>6/22/26</a:t>
             </a:fld>
             <a:endParaRPr lang="en-US" dirty="0"/>
           </a:p>
@@ -4285,7 +4285,7 @@
           <a:p>
             <a:fld id="{C764DE79-268F-4C1A-8933-263129D2AF90}" type="datetimeFigureOut">
               <a:rPr lang="en-US" dirty="0"/>
-              <a:t>5/14/26</a:t>
+              <a:t>6/22/26</a:t>
             </a:fld>
             <a:endParaRPr lang="en-US" dirty="0"/>
           </a:p>

</xml_diff>